<commit_message>
Inloggen vanaf het beginscherm: alleen de code overtypen (de knop in de mail opent Safari)
Co-Authored-By: Claude Opus 5.5 <noreply@anthropic.com>
Claude-Session: https://claude.ai/code/session_01JemqRo5kiX7AhhtzuggotQ
</commit_message>
<xml_diff>
--- a/docs/presentaties/ClubComm-ouders.pptx
+++ b/docs/presentaties/ClubComm-ouders.pptx
@@ -4606,7 +4606,7 @@
                 <a:ea typeface="Calibri" pitchFamily="34" charset="-122"/>
                 <a:cs typeface="Calibri" pitchFamily="34" charset="-120"/>
               </a:rPr>
-              <a:t>Open de mail</a:t>
+              <a:t>Typ de code over</a:t>
             </a:r>
             <a:endParaRPr lang="en-US" sz="1700" dirty="0"/>
           </a:p>
@@ -4623,7 +4623,7 @@
                 <a:ea typeface="Calibri" pitchFamily="34" charset="-122"/>
                 <a:cs typeface="Calibri" pitchFamily="34" charset="-120"/>
               </a:rPr>
-              <a:t>Tik op de knop in de mail, of typ de code van 6 cijfers over.</a:t>
+              <a:t>Je krijgt een mail met een code van 6 cijfers. Typ die over in de app.</a:t>
             </a:r>
             <a:endParaRPr lang="en-US" sz="1700" dirty="0"/>
           </a:p>
@@ -4708,7 +4708,7 @@
                 <a:ea typeface="Calibri" pitchFamily="34" charset="-122"/>
                 <a:cs typeface="Calibri" pitchFamily="34" charset="-120"/>
               </a:rPr>
-              <a:t>Zet ClubComm op je beginscherm. iPhone: Delen → Zet op beginscherm. Android: tik op ClubComm installeren.</a:t>
+              <a:t>Zet ClubComm op je beginscherm (iPhone: Delen → Zet op beginscherm). Log daarna in via het icoon en typ de code over: de knop in de mail opent Safari.</a:t>
             </a:r>
             <a:endParaRPr lang="en-US" sz="1300" dirty="0"/>
           </a:p>

</xml_diff>

<commit_message>
Voorblad handout ouders wervender: voordelen in drie punten en een oproep
Co-Authored-By: Claude Opus 5.5 <noreply@anthropic.com>
Claude-Session: https://claude.ai/code/session_01JemqRo5kiX7AhhtzuggotQ
</commit_message>
<xml_diff>
--- a/docs/presentaties/ClubComm-ouders.pptx
+++ b/docs/presentaties/ClubComm-ouders.pptx
@@ -1925,8 +1925,8 @@
         </p:nvSpPr>
         <p:spPr>
           <a:xfrm>
-            <a:off x="731520" y="2103120"/>
-            <a:ext cx="7132320" cy="1737360"/>
+            <a:off x="731520" y="1783080"/>
+            <a:ext cx="7315200" cy="777240"/>
           </a:xfrm>
           <a:prstGeom prst="rect">
             <a:avLst/>
@@ -1942,7 +1942,7 @@
               <a:buNone/>
             </a:pPr>
             <a:r>
-              <a:rPr lang="en-US" sz="4400" b="1" dirty="0">
+              <a:rPr lang="en-US" sz="4000" b="1" dirty="0">
                 <a:solidFill>
                   <a:srgbClr val="FFFFFF"/>
                 </a:solidFill>
@@ -1950,9 +1950,9 @@
                 <a:ea typeface="Calibri" pitchFamily="34" charset="-122"/>
                 <a:cs typeface="Calibri" pitchFamily="34" charset="-120"/>
               </a:rPr>
-              <a:t>ClubComm voor ouders</a:t>
-            </a:r>
-            <a:endParaRPr lang="en-US" sz="4400" dirty="0"/>
+              <a:t>Alles van het team op één plek</a:t>
+            </a:r>
+            <a:endParaRPr lang="en-US" sz="4000" dirty="0"/>
           </a:p>
         </p:txBody>
       </p:sp>
@@ -1964,8 +1964,8 @@
         </p:nvSpPr>
         <p:spPr>
           <a:xfrm>
-            <a:off x="731520" y="3931920"/>
-            <a:ext cx="6949440" cy="914400"/>
+            <a:off x="731520" y="2606040"/>
+            <a:ext cx="7132320" cy="457200"/>
           </a:xfrm>
           <a:prstGeom prst="rect">
             <a:avLst/>
@@ -1981,7 +1981,7 @@
               <a:buNone/>
             </a:pPr>
             <a:r>
-              <a:rPr lang="en-US" sz="2000" dirty="0">
+              <a:rPr lang="en-US" sz="1900" dirty="0">
                 <a:solidFill>
                   <a:srgbClr val="CADCFC"/>
                 </a:solidFill>
@@ -1989,22 +1989,66 @@
                 <a:ea typeface="Calibri" pitchFamily="34" charset="-122"/>
                 <a:cs typeface="Calibri" pitchFamily="34" charset="-120"/>
               </a:rPr>
-              <a:t>Afmelden, planning, vervoer en berichten van het team. Op je telefoon.</a:t>
-            </a:r>
-            <a:endParaRPr lang="en-US" sz="2000" dirty="0"/>
-          </a:p>
-        </p:txBody>
-      </p:sp>
-      <p:sp>
-        <p:nvSpPr>
-          <p:cNvPr id="6" name="Text 3"/>
-          <p:cNvSpPr txBox="1"/>
-          <p:nvPr/>
-        </p:nvSpPr>
-        <p:spPr>
-          <a:xfrm>
-            <a:off x="731520" y="5760720"/>
-            <a:ext cx="6949440" cy="365760"/>
+              <a:t>ClubComm voor ouders · O12 talententeam · RKSV DCG</a:t>
+            </a:r>
+            <a:endParaRPr lang="en-US" sz="1900" dirty="0"/>
+          </a:p>
+        </p:txBody>
+      </p:sp>
+      <p:sp>
+        <p:nvSpPr>
+          <p:cNvPr id="6" name="Shape 3"/>
+          <p:cNvSpPr/>
+          <p:nvPr/>
+        </p:nvSpPr>
+        <p:spPr>
+          <a:xfrm>
+            <a:off x="731520" y="3429000"/>
+            <a:ext cx="457200" cy="457200"/>
+          </a:xfrm>
+          <a:prstGeom prst="ellipse">
+            <a:avLst/>
+          </a:prstGeom>
+          <a:solidFill>
+            <a:srgbClr val="0D88F9"/>
+          </a:solidFill>
+          <a:ln/>
+        </p:spPr>
+      </p:sp>
+      <p:pic>
+        <p:nvPicPr>
+          <p:cNvPr id="7" name="Image 1" descr="preencoded.png">    </p:cNvPr>
+          <p:cNvPicPr>
+            <a:picLocks noChangeAspect="1"/>
+          </p:cNvPicPr>
+          <p:nvPr/>
+        </p:nvPicPr>
+        <p:blipFill>
+          <a:blip r:embed="rId2"/>
+          <a:stretch>
+            <a:fillRect/>
+          </a:stretch>
+        </p:blipFill>
+        <p:spPr>
+          <a:xfrm>
+            <a:off x="850392" y="3547872"/>
+            <a:ext cx="219456" cy="219456"/>
+          </a:xfrm>
+          <a:prstGeom prst="rect">
+            <a:avLst/>
+          </a:prstGeom>
+        </p:spPr>
+      </p:pic>
+      <p:sp>
+        <p:nvSpPr>
+          <p:cNvPr id="8" name="Text 4"/>
+          <p:cNvSpPr txBox="1"/>
+          <p:nvPr/>
+        </p:nvSpPr>
+        <p:spPr>
+          <a:xfrm>
+            <a:off x="1371600" y="3429000"/>
+            <a:ext cx="6400800" cy="457200"/>
           </a:xfrm>
           <a:prstGeom prst="rect">
             <a:avLst/>
@@ -2020,23 +2064,250 @@
               <a:buNone/>
             </a:pPr>
             <a:r>
-              <a:rPr lang="en-US" sz="1400" dirty="0">
-                <a:solidFill>
-                  <a:srgbClr val="9FB3D1"/>
-                </a:solidFill>
-                <a:latin typeface="Calibri" pitchFamily="34" charset="0"/>
-                <a:ea typeface="Calibri" pitchFamily="34" charset="-122"/>
-                <a:cs typeface="Calibri" pitchFamily="34" charset="-120"/>
-              </a:rPr>
-              <a:t>O12 talententeam · RKSV DCG</a:t>
-            </a:r>
-            <a:endParaRPr lang="en-US" sz="1400" dirty="0"/>
-          </a:p>
-        </p:txBody>
-      </p:sp>
-      <p:sp>
-        <p:nvSpPr>
-          <p:cNvPr id="7" name="Shape 4"/>
+              <a:rPr lang="en-US" sz="1800" dirty="0">
+                <a:solidFill>
+                  <a:srgbClr val="FFFFFF"/>
+                </a:solidFill>
+                <a:latin typeface="Calibri" pitchFamily="34" charset="0"/>
+                <a:ea typeface="Calibri" pitchFamily="34" charset="-122"/>
+                <a:cs typeface="Calibri" pitchFamily="34" charset="-120"/>
+              </a:rPr>
+              <a:t>Afmelden in 10 seconden</a:t>
+            </a:r>
+            <a:endParaRPr lang="en-US" sz="1800" dirty="0"/>
+          </a:p>
+        </p:txBody>
+      </p:sp>
+      <p:sp>
+        <p:nvSpPr>
+          <p:cNvPr id="9" name="Shape 5"/>
+          <p:cNvSpPr/>
+          <p:nvPr/>
+        </p:nvSpPr>
+        <p:spPr>
+          <a:xfrm>
+            <a:off x="731520" y="3977640"/>
+            <a:ext cx="457200" cy="457200"/>
+          </a:xfrm>
+          <a:prstGeom prst="ellipse">
+            <a:avLst/>
+          </a:prstGeom>
+          <a:solidFill>
+            <a:srgbClr val="0D88F9"/>
+          </a:solidFill>
+          <a:ln/>
+        </p:spPr>
+      </p:sp>
+      <p:pic>
+        <p:nvPicPr>
+          <p:cNvPr id="10" name="Image 2" descr="preencoded.png">    </p:cNvPr>
+          <p:cNvPicPr>
+            <a:picLocks noChangeAspect="1"/>
+          </p:cNvPicPr>
+          <p:nvPr/>
+        </p:nvPicPr>
+        <p:blipFill>
+          <a:blip r:embed="rId3"/>
+          <a:stretch>
+            <a:fillRect/>
+          </a:stretch>
+        </p:blipFill>
+        <p:spPr>
+          <a:xfrm>
+            <a:off x="850392" y="4096512"/>
+            <a:ext cx="219456" cy="219456"/>
+          </a:xfrm>
+          <a:prstGeom prst="rect">
+            <a:avLst/>
+          </a:prstGeom>
+        </p:spPr>
+      </p:pic>
+      <p:sp>
+        <p:nvSpPr>
+          <p:cNvPr id="11" name="Text 6"/>
+          <p:cNvSpPr txBox="1"/>
+          <p:nvPr/>
+        </p:nvSpPr>
+        <p:spPr>
+          <a:xfrm>
+            <a:off x="1371600" y="3977640"/>
+            <a:ext cx="6400800" cy="457200"/>
+          </a:xfrm>
+          <a:prstGeom prst="rect">
+            <a:avLst/>
+          </a:prstGeom>
+          <a:noFill/>
+          <a:ln/>
+        </p:spPr>
+        <p:txBody>
+          <a:bodyPr wrap="square" lIns="0" tIns="0" rIns="0" bIns="0" rtlCol="0" anchor="ctr"/>
+          <a:lstStyle/>
+          <a:p>
+            <a:pPr indent="0" marL="0">
+              <a:buNone/>
+            </a:pPr>
+            <a:r>
+              <a:rPr lang="en-US" sz="1800" dirty="0">
+                <a:solidFill>
+                  <a:srgbClr val="FFFFFF"/>
+                </a:solidFill>
+                <a:latin typeface="Calibri" pitchFamily="34" charset="0"/>
+                <a:ea typeface="Calibri" pitchFamily="34" charset="-122"/>
+                <a:cs typeface="Calibri" pitchFamily="34" charset="-120"/>
+              </a:rPr>
+              <a:t>Tijden, velden en adressen altijd bij de hand</a:t>
+            </a:r>
+            <a:endParaRPr lang="en-US" sz="1800" dirty="0"/>
+          </a:p>
+        </p:txBody>
+      </p:sp>
+      <p:sp>
+        <p:nvSpPr>
+          <p:cNvPr id="12" name="Shape 7"/>
+          <p:cNvSpPr/>
+          <p:nvPr/>
+        </p:nvSpPr>
+        <p:spPr>
+          <a:xfrm>
+            <a:off x="731520" y="4526280"/>
+            <a:ext cx="457200" cy="457200"/>
+          </a:xfrm>
+          <a:prstGeom prst="ellipse">
+            <a:avLst/>
+          </a:prstGeom>
+          <a:solidFill>
+            <a:srgbClr val="0D88F9"/>
+          </a:solidFill>
+          <a:ln/>
+        </p:spPr>
+      </p:sp>
+      <p:pic>
+        <p:nvPicPr>
+          <p:cNvPr id="13" name="Image 3" descr="preencoded.png">    </p:cNvPr>
+          <p:cNvPicPr>
+            <a:picLocks noChangeAspect="1"/>
+          </p:cNvPicPr>
+          <p:nvPr/>
+        </p:nvPicPr>
+        <p:blipFill>
+          <a:blip r:embed="rId4"/>
+          <a:stretch>
+            <a:fillRect/>
+          </a:stretch>
+        </p:blipFill>
+        <p:spPr>
+          <a:xfrm>
+            <a:off x="850392" y="4645152"/>
+            <a:ext cx="219456" cy="219456"/>
+          </a:xfrm>
+          <a:prstGeom prst="rect">
+            <a:avLst/>
+          </a:prstGeom>
+        </p:spPr>
+      </p:pic>
+      <p:sp>
+        <p:nvSpPr>
+          <p:cNvPr id="14" name="Text 8"/>
+          <p:cNvSpPr txBox="1"/>
+          <p:nvPr/>
+        </p:nvSpPr>
+        <p:spPr>
+          <a:xfrm>
+            <a:off x="1371600" y="4526280"/>
+            <a:ext cx="6400800" cy="457200"/>
+          </a:xfrm>
+          <a:prstGeom prst="rect">
+            <a:avLst/>
+          </a:prstGeom>
+          <a:noFill/>
+          <a:ln/>
+        </p:spPr>
+        <p:txBody>
+          <a:bodyPr wrap="square" lIns="0" tIns="0" rIns="0" bIns="0" rtlCol="0" anchor="ctr"/>
+          <a:lstStyle/>
+          <a:p>
+            <a:pPr indent="0" marL="0">
+              <a:buNone/>
+            </a:pPr>
+            <a:r>
+              <a:rPr lang="en-US" sz="1800" dirty="0">
+                <a:solidFill>
+                  <a:srgbClr val="FFFFFF"/>
+                </a:solidFill>
+                <a:latin typeface="Calibri" pitchFamily="34" charset="0"/>
+                <a:ea typeface="Calibri" pitchFamily="34" charset="-122"/>
+                <a:cs typeface="Calibri" pitchFamily="34" charset="-120"/>
+              </a:rPr>
+              <a:t>Samen rijden en meehelpen, zonder appgedoe</a:t>
+            </a:r>
+            <a:endParaRPr lang="en-US" sz="1800" dirty="0"/>
+          </a:p>
+        </p:txBody>
+      </p:sp>
+      <p:sp>
+        <p:nvSpPr>
+          <p:cNvPr id="15" name="Shape 9"/>
+          <p:cNvSpPr/>
+          <p:nvPr/>
+        </p:nvSpPr>
+        <p:spPr>
+          <a:xfrm>
+            <a:off x="731520" y="5257800"/>
+            <a:ext cx="4206240" cy="548640"/>
+          </a:xfrm>
+          <a:prstGeom prst="roundRect">
+            <a:avLst>
+              <a:gd name="adj" fmla="val 50000"/>
+            </a:avLst>
+          </a:prstGeom>
+          <a:solidFill>
+            <a:srgbClr val="F5A623"/>
+          </a:solidFill>
+          <a:ln/>
+        </p:spPr>
+      </p:sp>
+      <p:sp>
+        <p:nvSpPr>
+          <p:cNvPr id="16" name="Text 10"/>
+          <p:cNvSpPr txBox="1"/>
+          <p:nvPr/>
+        </p:nvSpPr>
+        <p:spPr>
+          <a:xfrm>
+            <a:off x="731520" y="5257800"/>
+            <a:ext cx="4206240" cy="548640"/>
+          </a:xfrm>
+          <a:prstGeom prst="rect">
+            <a:avLst/>
+          </a:prstGeom>
+          <a:noFill/>
+          <a:ln/>
+        </p:spPr>
+        <p:txBody>
+          <a:bodyPr wrap="square" lIns="0" tIns="0" rIns="0" bIns="0" rtlCol="0" anchor="ctr"/>
+          <a:lstStyle/>
+          <a:p>
+            <a:pPr algn="ctr" indent="0" marL="0">
+              <a:buNone/>
+            </a:pPr>
+            <a:r>
+              <a:rPr lang="en-US" sz="1600" b="1" dirty="0">
+                <a:solidFill>
+                  <a:srgbClr val="0B2545"/>
+                </a:solidFill>
+                <a:latin typeface="Calibri" pitchFamily="34" charset="0"/>
+                <a:ea typeface="Calibri" pitchFamily="34" charset="-122"/>
+                <a:cs typeface="Calibri" pitchFamily="34" charset="-120"/>
+              </a:rPr>
+              <a:t>Aanmelden duurt 1 minuut</a:t>
+            </a:r>
+            <a:endParaRPr lang="en-US" sz="1600" dirty="0"/>
+          </a:p>
+        </p:txBody>
+      </p:sp>
+      <p:sp>
+        <p:nvSpPr>
+          <p:cNvPr id="17" name="Shape 11"/>
           <p:cNvSpPr/>
           <p:nvPr/>
         </p:nvSpPr>
@@ -2051,7 +2322,7 @@
             </a:avLst>
           </a:prstGeom>
           <a:solidFill>
-            <a:srgbClr val="0B2545"/>
+            <a:srgbClr val="2A4A7A"/>
           </a:solidFill>
           <a:ln/>
           <a:effectLst>
@@ -2065,14 +2336,14 @@
       </p:sp>
       <p:pic>
         <p:nvPicPr>
-          <p:cNvPr id="8" name="Image 1" descr="/home/user/Clubcomm/docs/presentaties/beelden/ou-home.jpg">    </p:cNvPr>
+          <p:cNvPr id="18" name="Image 4" descr="/home/user/Clubcomm/docs/presentaties/beelden/ou-home.jpg">    </p:cNvPr>
           <p:cNvPicPr>
             <a:picLocks noChangeAspect="1"/>
           </p:cNvPicPr>
           <p:nvPr/>
         </p:nvPicPr>
         <p:blipFill>
-          <a:blip r:embed="rId2"/>
+          <a:blip r:embed="rId5"/>
           <a:stretch>
             <a:fillRect/>
           </a:stretch>

</xml_diff>